<commit_message>
Configuration update + retrieving information records from Power Pages API
</commit_message>
<xml_diff>
--- a/Power Pages Single Page App Demo.pptx
+++ b/Power Pages Single Page App Demo.pptx
@@ -4,11 +4,19 @@
   <p:sldMasterIdLst>
     <p:sldMasterId id="2147483648" r:id="rId1"/>
   </p:sldMasterIdLst>
+  <p:notesMasterIdLst>
+    <p:notesMasterId r:id="rId11"/>
+  </p:notesMasterIdLst>
   <p:sldIdLst>
     <p:sldId id="256" r:id="rId2"/>
     <p:sldId id="257" r:id="rId3"/>
     <p:sldId id="258" r:id="rId4"/>
     <p:sldId id="259" r:id="rId5"/>
+    <p:sldId id="260" r:id="rId6"/>
+    <p:sldId id="261" r:id="rId7"/>
+    <p:sldId id="262" r:id="rId8"/>
+    <p:sldId id="263" r:id="rId9"/>
+    <p:sldId id="264" r:id="rId10"/>
   </p:sldIdLst>
   <p:sldSz cx="12192000" cy="6858000"/>
   <p:notesSz cx="6858000" cy="9144000"/>
@@ -2822,6 +2830,544 @@
 </dgm:styleDef>
 </file>
 
+<file path=ppt/notesMasters/notesMaster1.xml><?xml version="1.0" encoding="utf-8"?>
+<p:notesMaster xmlns:a="http://schemas.openxmlformats.org/drawingml/2006/main" xmlns:r="http://schemas.openxmlformats.org/officeDocument/2006/relationships" xmlns:p="http://schemas.openxmlformats.org/presentationml/2006/main">
+  <p:cSld>
+    <p:bg>
+      <p:bgRef idx="1001">
+        <a:schemeClr val="bg1"/>
+      </p:bgRef>
+    </p:bg>
+    <p:spTree>
+      <p:nvGrpSpPr>
+        <p:cNvPr id="1" name=""/>
+        <p:cNvGrpSpPr/>
+        <p:nvPr/>
+      </p:nvGrpSpPr>
+      <p:grpSpPr>
+        <a:xfrm>
+          <a:off x="0" y="0"/>
+          <a:ext cx="0" cy="0"/>
+          <a:chOff x="0" y="0"/>
+          <a:chExt cx="0" cy="0"/>
+        </a:xfrm>
+      </p:grpSpPr>
+      <p:sp>
+        <p:nvSpPr>
+          <p:cNvPr id="2" name="Header Placeholder 1"/>
+          <p:cNvSpPr>
+            <a:spLocks noGrp="1"/>
+          </p:cNvSpPr>
+          <p:nvPr>
+            <p:ph type="hdr" sz="quarter"/>
+          </p:nvPr>
+        </p:nvSpPr>
+        <p:spPr>
+          <a:xfrm>
+            <a:off x="0" y="0"/>
+            <a:ext cx="2971800" cy="458788"/>
+          </a:xfrm>
+          <a:prstGeom prst="rect">
+            <a:avLst/>
+          </a:prstGeom>
+        </p:spPr>
+        <p:txBody>
+          <a:bodyPr vert="horz" lIns="91440" tIns="45720" rIns="91440" bIns="45720" rtlCol="0"/>
+          <a:lstStyle>
+            <a:lvl1pPr algn="l">
+              <a:defRPr sz="1200"/>
+            </a:lvl1pPr>
+          </a:lstStyle>
+          <a:p>
+            <a:endParaRPr lang="pl-PL"/>
+          </a:p>
+        </p:txBody>
+      </p:sp>
+      <p:sp>
+        <p:nvSpPr>
+          <p:cNvPr id="3" name="Date Placeholder 2"/>
+          <p:cNvSpPr>
+            <a:spLocks noGrp="1"/>
+          </p:cNvSpPr>
+          <p:nvPr>
+            <p:ph type="dt" idx="1"/>
+          </p:nvPr>
+        </p:nvSpPr>
+        <p:spPr>
+          <a:xfrm>
+            <a:off x="3884613" y="0"/>
+            <a:ext cx="2971800" cy="458788"/>
+          </a:xfrm>
+          <a:prstGeom prst="rect">
+            <a:avLst/>
+          </a:prstGeom>
+        </p:spPr>
+        <p:txBody>
+          <a:bodyPr vert="horz" lIns="91440" tIns="45720" rIns="91440" bIns="45720" rtlCol="0"/>
+          <a:lstStyle>
+            <a:lvl1pPr algn="r">
+              <a:defRPr sz="1200"/>
+            </a:lvl1pPr>
+          </a:lstStyle>
+          <a:p>
+            <a:fld id="{F04565E9-8E42-434E-900E-E247404B4C37}" type="datetimeFigureOut">
+              <a:rPr lang="pl-PL" smtClean="0"/>
+              <a:t>8.05.2026</a:t>
+            </a:fld>
+            <a:endParaRPr lang="pl-PL"/>
+          </a:p>
+        </p:txBody>
+      </p:sp>
+      <p:sp>
+        <p:nvSpPr>
+          <p:cNvPr id="4" name="Slide Image Placeholder 3"/>
+          <p:cNvSpPr>
+            <a:spLocks noGrp="1" noRot="1" noChangeAspect="1"/>
+          </p:cNvSpPr>
+          <p:nvPr>
+            <p:ph type="sldImg" idx="2"/>
+          </p:nvPr>
+        </p:nvSpPr>
+        <p:spPr>
+          <a:xfrm>
+            <a:off x="685800" y="1143000"/>
+            <a:ext cx="5486400" cy="3086100"/>
+          </a:xfrm>
+          <a:prstGeom prst="rect">
+            <a:avLst/>
+          </a:prstGeom>
+          <a:noFill/>
+          <a:ln w="12700">
+            <a:solidFill>
+              <a:prstClr val="black"/>
+            </a:solidFill>
+          </a:ln>
+        </p:spPr>
+        <p:txBody>
+          <a:bodyPr vert="horz" lIns="91440" tIns="45720" rIns="91440" bIns="45720" rtlCol="0" anchor="ctr"/>
+          <a:lstStyle/>
+          <a:p>
+            <a:endParaRPr lang="pl-PL"/>
+          </a:p>
+        </p:txBody>
+      </p:sp>
+      <p:sp>
+        <p:nvSpPr>
+          <p:cNvPr id="5" name="Notes Placeholder 4"/>
+          <p:cNvSpPr>
+            <a:spLocks noGrp="1"/>
+          </p:cNvSpPr>
+          <p:nvPr>
+            <p:ph type="body" sz="quarter" idx="3"/>
+          </p:nvPr>
+        </p:nvSpPr>
+        <p:spPr>
+          <a:xfrm>
+            <a:off x="685800" y="4400550"/>
+            <a:ext cx="5486400" cy="3600450"/>
+          </a:xfrm>
+          <a:prstGeom prst="rect">
+            <a:avLst/>
+          </a:prstGeom>
+        </p:spPr>
+        <p:txBody>
+          <a:bodyPr vert="horz" lIns="91440" tIns="45720" rIns="91440" bIns="45720" rtlCol="0"/>
+          <a:lstStyle/>
+          <a:p>
+            <a:pPr lvl="0"/>
+            <a:r>
+              <a:rPr lang="en-US"/>
+              <a:t>Click to edit Master text styles</a:t>
+            </a:r>
+          </a:p>
+          <a:p>
+            <a:pPr lvl="1"/>
+            <a:r>
+              <a:rPr lang="en-US"/>
+              <a:t>Second level</a:t>
+            </a:r>
+          </a:p>
+          <a:p>
+            <a:pPr lvl="2"/>
+            <a:r>
+              <a:rPr lang="en-US"/>
+              <a:t>Third level</a:t>
+            </a:r>
+          </a:p>
+          <a:p>
+            <a:pPr lvl="3"/>
+            <a:r>
+              <a:rPr lang="en-US"/>
+              <a:t>Fourth level</a:t>
+            </a:r>
+          </a:p>
+          <a:p>
+            <a:pPr lvl="4"/>
+            <a:r>
+              <a:rPr lang="en-US"/>
+              <a:t>Fifth level</a:t>
+            </a:r>
+            <a:endParaRPr lang="pl-PL"/>
+          </a:p>
+        </p:txBody>
+      </p:sp>
+      <p:sp>
+        <p:nvSpPr>
+          <p:cNvPr id="6" name="Footer Placeholder 5"/>
+          <p:cNvSpPr>
+            <a:spLocks noGrp="1"/>
+          </p:cNvSpPr>
+          <p:nvPr>
+            <p:ph type="ftr" sz="quarter" idx="4"/>
+          </p:nvPr>
+        </p:nvSpPr>
+        <p:spPr>
+          <a:xfrm>
+            <a:off x="0" y="8685213"/>
+            <a:ext cx="2971800" cy="458787"/>
+          </a:xfrm>
+          <a:prstGeom prst="rect">
+            <a:avLst/>
+          </a:prstGeom>
+        </p:spPr>
+        <p:txBody>
+          <a:bodyPr vert="horz" lIns="91440" tIns="45720" rIns="91440" bIns="45720" rtlCol="0" anchor="b"/>
+          <a:lstStyle>
+            <a:lvl1pPr algn="l">
+              <a:defRPr sz="1200"/>
+            </a:lvl1pPr>
+          </a:lstStyle>
+          <a:p>
+            <a:endParaRPr lang="pl-PL"/>
+          </a:p>
+        </p:txBody>
+      </p:sp>
+      <p:sp>
+        <p:nvSpPr>
+          <p:cNvPr id="7" name="Slide Number Placeholder 6"/>
+          <p:cNvSpPr>
+            <a:spLocks noGrp="1"/>
+          </p:cNvSpPr>
+          <p:nvPr>
+            <p:ph type="sldNum" sz="quarter" idx="5"/>
+          </p:nvPr>
+        </p:nvSpPr>
+        <p:spPr>
+          <a:xfrm>
+            <a:off x="3884613" y="8685213"/>
+            <a:ext cx="2971800" cy="458787"/>
+          </a:xfrm>
+          <a:prstGeom prst="rect">
+            <a:avLst/>
+          </a:prstGeom>
+        </p:spPr>
+        <p:txBody>
+          <a:bodyPr vert="horz" lIns="91440" tIns="45720" rIns="91440" bIns="45720" rtlCol="0" anchor="b"/>
+          <a:lstStyle>
+            <a:lvl1pPr algn="r">
+              <a:defRPr sz="1200"/>
+            </a:lvl1pPr>
+          </a:lstStyle>
+          <a:p>
+            <a:fld id="{5AC67EFE-9B8E-4029-AC02-C061BB620F1F}" type="slidenum">
+              <a:rPr lang="pl-PL" smtClean="0"/>
+              <a:t>‹#›</a:t>
+            </a:fld>
+            <a:endParaRPr lang="pl-PL"/>
+          </a:p>
+        </p:txBody>
+      </p:sp>
+    </p:spTree>
+    <p:extLst>
+      <p:ext uri="{BB962C8B-B14F-4D97-AF65-F5344CB8AC3E}">
+        <p14:creationId xmlns:p14="http://schemas.microsoft.com/office/powerpoint/2010/main" val="555414176"/>
+      </p:ext>
+    </p:extLst>
+  </p:cSld>
+  <p:clrMap bg1="lt1" tx1="dk1" bg2="lt2" tx2="dk2" accent1="accent1" accent2="accent2" accent3="accent3" accent4="accent4" accent5="accent5" accent6="accent6" hlink="hlink" folHlink="folHlink"/>
+  <p:notesStyle>
+    <a:lvl1pPr marL="0" algn="l" defTabSz="914400" rtl="0" eaLnBrk="1" latinLnBrk="0" hangingPunct="1">
+      <a:defRPr sz="1200" kern="1200">
+        <a:solidFill>
+          <a:schemeClr val="tx1"/>
+        </a:solidFill>
+        <a:latin typeface="+mn-lt"/>
+        <a:ea typeface="+mn-ea"/>
+        <a:cs typeface="+mn-cs"/>
+      </a:defRPr>
+    </a:lvl1pPr>
+    <a:lvl2pPr marL="457200" algn="l" defTabSz="914400" rtl="0" eaLnBrk="1" latinLnBrk="0" hangingPunct="1">
+      <a:defRPr sz="1200" kern="1200">
+        <a:solidFill>
+          <a:schemeClr val="tx1"/>
+        </a:solidFill>
+        <a:latin typeface="+mn-lt"/>
+        <a:ea typeface="+mn-ea"/>
+        <a:cs typeface="+mn-cs"/>
+      </a:defRPr>
+    </a:lvl2pPr>
+    <a:lvl3pPr marL="914400" algn="l" defTabSz="914400" rtl="0" eaLnBrk="1" latinLnBrk="0" hangingPunct="1">
+      <a:defRPr sz="1200" kern="1200">
+        <a:solidFill>
+          <a:schemeClr val="tx1"/>
+        </a:solidFill>
+        <a:latin typeface="+mn-lt"/>
+        <a:ea typeface="+mn-ea"/>
+        <a:cs typeface="+mn-cs"/>
+      </a:defRPr>
+    </a:lvl3pPr>
+    <a:lvl4pPr marL="1371600" algn="l" defTabSz="914400" rtl="0" eaLnBrk="1" latinLnBrk="0" hangingPunct="1">
+      <a:defRPr sz="1200" kern="1200">
+        <a:solidFill>
+          <a:schemeClr val="tx1"/>
+        </a:solidFill>
+        <a:latin typeface="+mn-lt"/>
+        <a:ea typeface="+mn-ea"/>
+        <a:cs typeface="+mn-cs"/>
+      </a:defRPr>
+    </a:lvl4pPr>
+    <a:lvl5pPr marL="1828800" algn="l" defTabSz="914400" rtl="0" eaLnBrk="1" latinLnBrk="0" hangingPunct="1">
+      <a:defRPr sz="1200" kern="1200">
+        <a:solidFill>
+          <a:schemeClr val="tx1"/>
+        </a:solidFill>
+        <a:latin typeface="+mn-lt"/>
+        <a:ea typeface="+mn-ea"/>
+        <a:cs typeface="+mn-cs"/>
+      </a:defRPr>
+    </a:lvl5pPr>
+    <a:lvl6pPr marL="2286000" algn="l" defTabSz="914400" rtl="0" eaLnBrk="1" latinLnBrk="0" hangingPunct="1">
+      <a:defRPr sz="1200" kern="1200">
+        <a:solidFill>
+          <a:schemeClr val="tx1"/>
+        </a:solidFill>
+        <a:latin typeface="+mn-lt"/>
+        <a:ea typeface="+mn-ea"/>
+        <a:cs typeface="+mn-cs"/>
+      </a:defRPr>
+    </a:lvl6pPr>
+    <a:lvl7pPr marL="2743200" algn="l" defTabSz="914400" rtl="0" eaLnBrk="1" latinLnBrk="0" hangingPunct="1">
+      <a:defRPr sz="1200" kern="1200">
+        <a:solidFill>
+          <a:schemeClr val="tx1"/>
+        </a:solidFill>
+        <a:latin typeface="+mn-lt"/>
+        <a:ea typeface="+mn-ea"/>
+        <a:cs typeface="+mn-cs"/>
+      </a:defRPr>
+    </a:lvl7pPr>
+    <a:lvl8pPr marL="3200400" algn="l" defTabSz="914400" rtl="0" eaLnBrk="1" latinLnBrk="0" hangingPunct="1">
+      <a:defRPr sz="1200" kern="1200">
+        <a:solidFill>
+          <a:schemeClr val="tx1"/>
+        </a:solidFill>
+        <a:latin typeface="+mn-lt"/>
+        <a:ea typeface="+mn-ea"/>
+        <a:cs typeface="+mn-cs"/>
+      </a:defRPr>
+    </a:lvl8pPr>
+    <a:lvl9pPr marL="3657600" algn="l" defTabSz="914400" rtl="0" eaLnBrk="1" latinLnBrk="0" hangingPunct="1">
+      <a:defRPr sz="1200" kern="1200">
+        <a:solidFill>
+          <a:schemeClr val="tx1"/>
+        </a:solidFill>
+        <a:latin typeface="+mn-lt"/>
+        <a:ea typeface="+mn-ea"/>
+        <a:cs typeface="+mn-cs"/>
+      </a:defRPr>
+    </a:lvl9pPr>
+  </p:notesStyle>
+</p:notesMaster>
+</file>
+
+<file path=ppt/notesSlides/notesSlide1.xml><?xml version="1.0" encoding="utf-8"?>
+<p:notes xmlns:a="http://schemas.openxmlformats.org/drawingml/2006/main" xmlns:r="http://schemas.openxmlformats.org/officeDocument/2006/relationships" xmlns:p="http://schemas.openxmlformats.org/presentationml/2006/main">
+  <p:cSld>
+    <p:spTree>
+      <p:nvGrpSpPr>
+        <p:cNvPr id="1" name=""/>
+        <p:cNvGrpSpPr/>
+        <p:nvPr/>
+      </p:nvGrpSpPr>
+      <p:grpSpPr>
+        <a:xfrm>
+          <a:off x="0" y="0"/>
+          <a:ext cx="0" cy="0"/>
+          <a:chOff x="0" y="0"/>
+          <a:chExt cx="0" cy="0"/>
+        </a:xfrm>
+      </p:grpSpPr>
+      <p:sp>
+        <p:nvSpPr>
+          <p:cNvPr id="2" name="Slide Image Placeholder 1"/>
+          <p:cNvSpPr>
+            <a:spLocks noGrp="1" noRot="1" noChangeAspect="1"/>
+          </p:cNvSpPr>
+          <p:nvPr>
+            <p:ph type="sldImg"/>
+          </p:nvPr>
+        </p:nvSpPr>
+        <p:spPr/>
+      </p:sp>
+      <p:sp>
+        <p:nvSpPr>
+          <p:cNvPr id="3" name="Notes Placeholder 2"/>
+          <p:cNvSpPr>
+            <a:spLocks noGrp="1"/>
+          </p:cNvSpPr>
+          <p:nvPr>
+            <p:ph type="body" idx="1"/>
+          </p:nvPr>
+        </p:nvSpPr>
+        <p:spPr/>
+        <p:txBody>
+          <a:bodyPr/>
+          <a:lstStyle/>
+          <a:p>
+            <a:pPr marL="0" indent="0">
+              <a:buNone/>
+            </a:pPr>
+            <a:r>
+              <a:rPr lang="pl-PL" dirty="0"/>
+              <a:t>Plan:</a:t>
+            </a:r>
+          </a:p>
+          <a:p>
+            <a:pPr marL="228600" indent="-228600">
+              <a:buAutoNum type="arabicPeriod"/>
+            </a:pPr>
+            <a:r>
+              <a:rPr lang="pl-PL" dirty="0"/>
+              <a:t>Setup </a:t>
+            </a:r>
+            <a:r>
+              <a:rPr lang="pl-PL" dirty="0" err="1"/>
+              <a:t>initial</a:t>
+            </a:r>
+            <a:r>
+              <a:rPr lang="pl-PL" dirty="0"/>
+              <a:t> </a:t>
+            </a:r>
+            <a:r>
+              <a:rPr lang="pl-PL" dirty="0" err="1"/>
+              <a:t>Page</a:t>
+            </a:r>
+            <a:r>
+              <a:rPr lang="pl-PL" dirty="0"/>
+              <a:t> layout</a:t>
+            </a:r>
+          </a:p>
+          <a:p>
+            <a:pPr marL="228600" indent="-228600">
+              <a:buAutoNum type="arabicPeriod"/>
+            </a:pPr>
+            <a:r>
+              <a:rPr lang="pl-PL" dirty="0" err="1"/>
+              <a:t>Implement</a:t>
+            </a:r>
+            <a:r>
+              <a:rPr lang="pl-PL" dirty="0"/>
+              <a:t> </a:t>
+            </a:r>
+            <a:r>
+              <a:rPr lang="pl-PL" dirty="0" err="1"/>
+              <a:t>retrieving</a:t>
+            </a:r>
+            <a:r>
+              <a:rPr lang="pl-PL" dirty="0"/>
+              <a:t> data from </a:t>
+            </a:r>
+            <a:r>
+              <a:rPr lang="pl-PL" dirty="0" err="1"/>
+              <a:t>Dataverse</a:t>
+            </a:r>
+            <a:endParaRPr lang="pl-PL" dirty="0"/>
+          </a:p>
+          <a:p>
+            <a:pPr marL="228600" indent="-228600">
+              <a:buAutoNum type="arabicPeriod"/>
+            </a:pPr>
+            <a:r>
+              <a:rPr lang="pl-PL" dirty="0" err="1"/>
+              <a:t>Implementing</a:t>
+            </a:r>
+            <a:r>
+              <a:rPr lang="pl-PL" dirty="0"/>
+              <a:t> Power </a:t>
+            </a:r>
+            <a:r>
+              <a:rPr lang="pl-PL" dirty="0" err="1"/>
+              <a:t>Automate</a:t>
+            </a:r>
+            <a:r>
+              <a:rPr lang="pl-PL" dirty="0"/>
+              <a:t> Call</a:t>
+            </a:r>
+          </a:p>
+          <a:p>
+            <a:pPr marL="228600" indent="-228600">
+              <a:buAutoNum type="arabicPeriod"/>
+            </a:pPr>
+            <a:r>
+              <a:rPr lang="pl-PL" dirty="0" err="1"/>
+              <a:t>Implement</a:t>
+            </a:r>
+            <a:r>
+              <a:rPr lang="pl-PL" dirty="0"/>
+              <a:t> </a:t>
+            </a:r>
+            <a:r>
+              <a:rPr lang="pl-PL" dirty="0" err="1"/>
+              <a:t>authentication</a:t>
+            </a:r>
+            <a:r>
+              <a:rPr lang="pl-PL" dirty="0"/>
+              <a:t> and </a:t>
+            </a:r>
+            <a:r>
+              <a:rPr lang="pl-PL" dirty="0" err="1"/>
+              <a:t>authorization</a:t>
+            </a:r>
+            <a:endParaRPr lang="pl-PL" dirty="0"/>
+          </a:p>
+        </p:txBody>
+      </p:sp>
+      <p:sp>
+        <p:nvSpPr>
+          <p:cNvPr id="4" name="Slide Number Placeholder 3"/>
+          <p:cNvSpPr>
+            <a:spLocks noGrp="1"/>
+          </p:cNvSpPr>
+          <p:nvPr>
+            <p:ph type="sldNum" sz="quarter" idx="5"/>
+          </p:nvPr>
+        </p:nvSpPr>
+        <p:spPr/>
+        <p:txBody>
+          <a:bodyPr/>
+          <a:lstStyle/>
+          <a:p>
+            <a:fld id="{5AC67EFE-9B8E-4029-AC02-C061BB620F1F}" type="slidenum">
+              <a:rPr lang="pl-PL" smtClean="0"/>
+              <a:t>1</a:t>
+            </a:fld>
+            <a:endParaRPr lang="pl-PL"/>
+          </a:p>
+        </p:txBody>
+      </p:sp>
+    </p:spTree>
+    <p:extLst>
+      <p:ext uri="{BB962C8B-B14F-4D97-AF65-F5344CB8AC3E}">
+        <p14:creationId xmlns:p14="http://schemas.microsoft.com/office/powerpoint/2010/main" val="2752988124"/>
+      </p:ext>
+    </p:extLst>
+  </p:cSld>
+  <p:clrMapOvr>
+    <a:masterClrMapping/>
+  </p:clrMapOvr>
+</p:notes>
+</file>
+
 <file path=ppt/slideLayouts/slideLayout1.xml><?xml version="1.0" encoding="utf-8"?>
 <p:sldLayout xmlns:a="http://schemas.openxmlformats.org/drawingml/2006/main" xmlns:r="http://schemas.openxmlformats.org/officeDocument/2006/relationships" xmlns:p="http://schemas.openxmlformats.org/presentationml/2006/main" type="title" preserve="1">
   <p:cSld name="Title Slide">
@@ -2971,7 +3517,7 @@
           <a:p>
             <a:fld id="{ACAB5360-B84C-4BBD-9312-60A0E9976EC2}" type="datetimeFigureOut">
               <a:rPr lang="pl-PL" smtClean="0"/>
-              <a:t>4.05.2026</a:t>
+              <a:t>8.05.2026</a:t>
             </a:fld>
             <a:endParaRPr lang="pl-PL"/>
           </a:p>
@@ -3171,7 +3717,7 @@
           <a:p>
             <a:fld id="{ACAB5360-B84C-4BBD-9312-60A0E9976EC2}" type="datetimeFigureOut">
               <a:rPr lang="pl-PL" smtClean="0"/>
-              <a:t>4.05.2026</a:t>
+              <a:t>8.05.2026</a:t>
             </a:fld>
             <a:endParaRPr lang="pl-PL"/>
           </a:p>
@@ -3381,7 +3927,7 @@
           <a:p>
             <a:fld id="{ACAB5360-B84C-4BBD-9312-60A0E9976EC2}" type="datetimeFigureOut">
               <a:rPr lang="pl-PL" smtClean="0"/>
-              <a:t>4.05.2026</a:t>
+              <a:t>8.05.2026</a:t>
             </a:fld>
             <a:endParaRPr lang="pl-PL"/>
           </a:p>
@@ -3581,7 +4127,7 @@
           <a:p>
             <a:fld id="{ACAB5360-B84C-4BBD-9312-60A0E9976EC2}" type="datetimeFigureOut">
               <a:rPr lang="pl-PL" smtClean="0"/>
-              <a:t>4.05.2026</a:t>
+              <a:t>8.05.2026</a:t>
             </a:fld>
             <a:endParaRPr lang="pl-PL"/>
           </a:p>
@@ -3857,7 +4403,7 @@
           <a:p>
             <a:fld id="{ACAB5360-B84C-4BBD-9312-60A0E9976EC2}" type="datetimeFigureOut">
               <a:rPr lang="pl-PL" smtClean="0"/>
-              <a:t>4.05.2026</a:t>
+              <a:t>8.05.2026</a:t>
             </a:fld>
             <a:endParaRPr lang="pl-PL"/>
           </a:p>
@@ -4125,7 +4671,7 @@
           <a:p>
             <a:fld id="{ACAB5360-B84C-4BBD-9312-60A0E9976EC2}" type="datetimeFigureOut">
               <a:rPr lang="pl-PL" smtClean="0"/>
-              <a:t>4.05.2026</a:t>
+              <a:t>8.05.2026</a:t>
             </a:fld>
             <a:endParaRPr lang="pl-PL"/>
           </a:p>
@@ -4540,7 +5086,7 @@
           <a:p>
             <a:fld id="{ACAB5360-B84C-4BBD-9312-60A0E9976EC2}" type="datetimeFigureOut">
               <a:rPr lang="pl-PL" smtClean="0"/>
-              <a:t>4.05.2026</a:t>
+              <a:t>8.05.2026</a:t>
             </a:fld>
             <a:endParaRPr lang="pl-PL"/>
           </a:p>
@@ -4682,7 +5228,7 @@
           <a:p>
             <a:fld id="{ACAB5360-B84C-4BBD-9312-60A0E9976EC2}" type="datetimeFigureOut">
               <a:rPr lang="pl-PL" smtClean="0"/>
-              <a:t>4.05.2026</a:t>
+              <a:t>8.05.2026</a:t>
             </a:fld>
             <a:endParaRPr lang="pl-PL"/>
           </a:p>
@@ -4795,7 +5341,7 @@
           <a:p>
             <a:fld id="{ACAB5360-B84C-4BBD-9312-60A0E9976EC2}" type="datetimeFigureOut">
               <a:rPr lang="pl-PL" smtClean="0"/>
-              <a:t>4.05.2026</a:t>
+              <a:t>8.05.2026</a:t>
             </a:fld>
             <a:endParaRPr lang="pl-PL"/>
           </a:p>
@@ -5108,7 +5654,7 @@
           <a:p>
             <a:fld id="{ACAB5360-B84C-4BBD-9312-60A0E9976EC2}" type="datetimeFigureOut">
               <a:rPr lang="pl-PL" smtClean="0"/>
-              <a:t>4.05.2026</a:t>
+              <a:t>8.05.2026</a:t>
             </a:fld>
             <a:endParaRPr lang="pl-PL"/>
           </a:p>
@@ -5397,7 +5943,7 @@
           <a:p>
             <a:fld id="{ACAB5360-B84C-4BBD-9312-60A0E9976EC2}" type="datetimeFigureOut">
               <a:rPr lang="pl-PL" smtClean="0"/>
-              <a:t>4.05.2026</a:t>
+              <a:t>8.05.2026</a:t>
             </a:fld>
             <a:endParaRPr lang="pl-PL"/>
           </a:p>
@@ -5640,7 +6186,7 @@
           <a:p>
             <a:fld id="{ACAB5360-B84C-4BBD-9312-60A0E9976EC2}" type="datetimeFigureOut">
               <a:rPr lang="pl-PL" smtClean="0"/>
-              <a:t>4.05.2026</a:t>
+              <a:t>8.05.2026</a:t>
             </a:fld>
             <a:endParaRPr lang="pl-PL"/>
           </a:p>
@@ -6930,6 +7476,916 @@
 </p:sld>
 </file>
 
+<file path=ppt/slides/slide5.xml><?xml version="1.0" encoding="utf-8"?>
+<p:sld xmlns:a="http://schemas.openxmlformats.org/drawingml/2006/main" xmlns:r="http://schemas.openxmlformats.org/officeDocument/2006/relationships" xmlns:p="http://schemas.openxmlformats.org/presentationml/2006/main">
+  <p:cSld>
+    <p:spTree>
+      <p:nvGrpSpPr>
+        <p:cNvPr id="1" name=""/>
+        <p:cNvGrpSpPr/>
+        <p:nvPr/>
+      </p:nvGrpSpPr>
+      <p:grpSpPr>
+        <a:xfrm>
+          <a:off x="0" y="0"/>
+          <a:ext cx="0" cy="0"/>
+          <a:chOff x="0" y="0"/>
+          <a:chExt cx="0" cy="0"/>
+        </a:xfrm>
+      </p:grpSpPr>
+      <p:sp>
+        <p:nvSpPr>
+          <p:cNvPr id="2" name="Title 1">
+            <a:extLst>
+              <a:ext uri="{FF2B5EF4-FFF2-40B4-BE49-F238E27FC236}">
+                <a16:creationId xmlns:a16="http://schemas.microsoft.com/office/drawing/2014/main" id="{BA18DEDF-D710-D3FC-F927-46B91392336D}"/>
+              </a:ext>
+            </a:extLst>
+          </p:cNvPr>
+          <p:cNvSpPr>
+            <a:spLocks noGrp="1"/>
+          </p:cNvSpPr>
+          <p:nvPr>
+            <p:ph type="title"/>
+          </p:nvPr>
+        </p:nvSpPr>
+        <p:spPr/>
+        <p:txBody>
+          <a:bodyPr/>
+          <a:lstStyle/>
+          <a:p>
+            <a:r>
+              <a:rPr lang="pl-PL" dirty="0"/>
+              <a:t>Microsoft </a:t>
+            </a:r>
+            <a:r>
+              <a:rPr lang="pl-PL" dirty="0" err="1"/>
+              <a:t>Entra</a:t>
+            </a:r>
+            <a:r>
+              <a:rPr lang="pl-PL" dirty="0"/>
+              <a:t> </a:t>
+            </a:r>
+            <a:r>
+              <a:rPr lang="pl-PL" dirty="0" err="1"/>
+              <a:t>External</a:t>
+            </a:r>
+            <a:r>
+              <a:rPr lang="pl-PL" dirty="0"/>
+              <a:t> ID </a:t>
+            </a:r>
+            <a:r>
+              <a:rPr lang="pl-PL" dirty="0" err="1"/>
+              <a:t>authentication</a:t>
+            </a:r>
+            <a:endParaRPr lang="pl-PL" dirty="0"/>
+          </a:p>
+        </p:txBody>
+      </p:sp>
+      <p:sp>
+        <p:nvSpPr>
+          <p:cNvPr id="3" name="Content Placeholder 2">
+            <a:extLst>
+              <a:ext uri="{FF2B5EF4-FFF2-40B4-BE49-F238E27FC236}">
+                <a16:creationId xmlns:a16="http://schemas.microsoft.com/office/drawing/2014/main" id="{B85830E9-29A0-F784-9CEF-32B0F29795BF}"/>
+              </a:ext>
+            </a:extLst>
+          </p:cNvPr>
+          <p:cNvSpPr>
+            <a:spLocks noGrp="1"/>
+          </p:cNvSpPr>
+          <p:nvPr>
+            <p:ph idx="1"/>
+          </p:nvPr>
+        </p:nvSpPr>
+        <p:spPr>
+          <a:xfrm>
+            <a:off x="838200" y="1858283"/>
+            <a:ext cx="10515600" cy="4351338"/>
+          </a:xfrm>
+        </p:spPr>
+        <p:txBody>
+          <a:bodyPr/>
+          <a:lstStyle/>
+          <a:p>
+            <a:r>
+              <a:rPr lang="pl-PL" dirty="0">
+                <a:hlinkClick r:id="rId2"/>
+              </a:rPr>
+              <a:t>https://learn.microsoft.com/en-us/power-pages/security/authentication/entra-external-id</a:t>
+            </a:r>
+            <a:endParaRPr lang="pl-PL" dirty="0"/>
+          </a:p>
+          <a:p>
+            <a:r>
+              <a:rPr lang="pl-PL" dirty="0" err="1"/>
+              <a:t>Remember</a:t>
+            </a:r>
+            <a:r>
+              <a:rPr lang="pl-PL" dirty="0"/>
+              <a:t> </a:t>
+            </a:r>
+            <a:r>
+              <a:rPr lang="pl-PL" dirty="0" err="1"/>
+              <a:t>about</a:t>
+            </a:r>
+            <a:r>
+              <a:rPr lang="pl-PL" dirty="0"/>
+              <a:t> </a:t>
+            </a:r>
+            <a:r>
+              <a:rPr lang="pl-PL" dirty="0" err="1"/>
+              <a:t>restarting</a:t>
+            </a:r>
+            <a:r>
+              <a:rPr lang="pl-PL" dirty="0"/>
+              <a:t> </a:t>
+            </a:r>
+            <a:r>
+              <a:rPr lang="pl-PL" dirty="0" err="1"/>
+              <a:t>site</a:t>
+            </a:r>
+            <a:r>
+              <a:rPr lang="pl-PL" dirty="0"/>
+              <a:t> in Power Platform admin </a:t>
+            </a:r>
+            <a:r>
+              <a:rPr lang="pl-PL" dirty="0" err="1"/>
+              <a:t>center</a:t>
+            </a:r>
+            <a:r>
+              <a:rPr lang="pl-PL" dirty="0"/>
+              <a:t>!</a:t>
+            </a:r>
+          </a:p>
+        </p:txBody>
+      </p:sp>
+    </p:spTree>
+    <p:extLst>
+      <p:ext uri="{BB962C8B-B14F-4D97-AF65-F5344CB8AC3E}">
+        <p14:creationId xmlns:p14="http://schemas.microsoft.com/office/powerpoint/2010/main" val="1123724739"/>
+      </p:ext>
+    </p:extLst>
+  </p:cSld>
+  <p:clrMapOvr>
+    <a:masterClrMapping/>
+  </p:clrMapOvr>
+</p:sld>
+</file>
+
+<file path=ppt/slides/slide6.xml><?xml version="1.0" encoding="utf-8"?>
+<p:sld xmlns:a="http://schemas.openxmlformats.org/drawingml/2006/main" xmlns:r="http://schemas.openxmlformats.org/officeDocument/2006/relationships" xmlns:p="http://schemas.openxmlformats.org/presentationml/2006/main">
+  <p:cSld>
+    <p:spTree>
+      <p:nvGrpSpPr>
+        <p:cNvPr id="1" name=""/>
+        <p:cNvGrpSpPr/>
+        <p:nvPr/>
+      </p:nvGrpSpPr>
+      <p:grpSpPr>
+        <a:xfrm>
+          <a:off x="0" y="0"/>
+          <a:ext cx="0" cy="0"/>
+          <a:chOff x="0" y="0"/>
+          <a:chExt cx="0" cy="0"/>
+        </a:xfrm>
+      </p:grpSpPr>
+      <p:sp>
+        <p:nvSpPr>
+          <p:cNvPr id="2" name="Title 1">
+            <a:extLst>
+              <a:ext uri="{FF2B5EF4-FFF2-40B4-BE49-F238E27FC236}">
+                <a16:creationId xmlns:a16="http://schemas.microsoft.com/office/drawing/2014/main" id="{CA565427-6948-D449-6E73-F1C5D7F42DCC}"/>
+              </a:ext>
+            </a:extLst>
+          </p:cNvPr>
+          <p:cNvSpPr>
+            <a:spLocks noGrp="1"/>
+          </p:cNvSpPr>
+          <p:nvPr>
+            <p:ph type="title"/>
+          </p:nvPr>
+        </p:nvSpPr>
+        <p:spPr/>
+        <p:txBody>
+          <a:bodyPr/>
+          <a:lstStyle/>
+          <a:p>
+            <a:r>
+              <a:rPr lang="pl-PL" dirty="0"/>
+              <a:t>Data Access</a:t>
+            </a:r>
+          </a:p>
+        </p:txBody>
+      </p:sp>
+      <p:sp>
+        <p:nvSpPr>
+          <p:cNvPr id="3" name="Content Placeholder 2">
+            <a:extLst>
+              <a:ext uri="{FF2B5EF4-FFF2-40B4-BE49-F238E27FC236}">
+                <a16:creationId xmlns:a16="http://schemas.microsoft.com/office/drawing/2014/main" id="{EE19B220-AC06-665F-ECCB-41A5C82F638E}"/>
+              </a:ext>
+            </a:extLst>
+          </p:cNvPr>
+          <p:cNvSpPr>
+            <a:spLocks noGrp="1"/>
+          </p:cNvSpPr>
+          <p:nvPr>
+            <p:ph idx="1"/>
+          </p:nvPr>
+        </p:nvSpPr>
+        <p:spPr/>
+        <p:txBody>
+          <a:bodyPr/>
+          <a:lstStyle/>
+          <a:p>
+            <a:r>
+              <a:rPr lang="pl-PL" dirty="0" err="1"/>
+              <a:t>Add</a:t>
+            </a:r>
+            <a:r>
+              <a:rPr lang="pl-PL" dirty="0"/>
+              <a:t> </a:t>
+            </a:r>
+            <a:r>
+              <a:rPr lang="pl-PL" dirty="0" err="1"/>
+              <a:t>following</a:t>
+            </a:r>
+            <a:r>
+              <a:rPr lang="pl-PL" dirty="0"/>
+              <a:t> </a:t>
+            </a:r>
+            <a:r>
+              <a:rPr lang="pl-PL" dirty="0" err="1"/>
+              <a:t>site</a:t>
+            </a:r>
+            <a:r>
+              <a:rPr lang="pl-PL" dirty="0"/>
+              <a:t> </a:t>
+            </a:r>
+            <a:r>
+              <a:rPr lang="pl-PL" dirty="0" err="1"/>
+              <a:t>settings</a:t>
+            </a:r>
+            <a:r>
+              <a:rPr lang="pl-PL" dirty="0"/>
+              <a:t>: </a:t>
+            </a:r>
+          </a:p>
+          <a:p>
+            <a:pPr lvl="1"/>
+            <a:r>
+              <a:rPr lang="pl-PL" dirty="0" err="1"/>
+              <a:t>Webapi</a:t>
+            </a:r>
+            <a:r>
+              <a:rPr lang="pl-PL" dirty="0"/>
+              <a:t>/</a:t>
+            </a:r>
+            <a:r>
+              <a:rPr lang="pl-PL" dirty="0" err="1"/>
+              <a:t>pg_information</a:t>
+            </a:r>
+            <a:r>
+              <a:rPr lang="pl-PL" dirty="0"/>
+              <a:t>/</a:t>
+            </a:r>
+            <a:r>
+              <a:rPr lang="pl-PL" dirty="0" err="1"/>
+              <a:t>enabled</a:t>
+            </a:r>
+            <a:r>
+              <a:rPr lang="pl-PL" dirty="0"/>
+              <a:t> = </a:t>
+            </a:r>
+            <a:r>
+              <a:rPr lang="pl-PL" dirty="0" err="1"/>
+              <a:t>true</a:t>
+            </a:r>
+            <a:endParaRPr lang="pl-PL" dirty="0"/>
+          </a:p>
+          <a:p>
+            <a:pPr lvl="1"/>
+            <a:r>
+              <a:rPr lang="pl-PL" dirty="0" err="1"/>
+              <a:t>Webapi</a:t>
+            </a:r>
+            <a:r>
+              <a:rPr lang="pl-PL" dirty="0"/>
+              <a:t>/</a:t>
+            </a:r>
+            <a:r>
+              <a:rPr lang="pl-PL" dirty="0" err="1"/>
+              <a:t>pg_information</a:t>
+            </a:r>
+            <a:r>
+              <a:rPr lang="pl-PL" dirty="0"/>
+              <a:t>/</a:t>
+            </a:r>
+            <a:r>
+              <a:rPr lang="pl-PL" dirty="0" err="1"/>
+              <a:t>fields</a:t>
+            </a:r>
+            <a:r>
+              <a:rPr lang="pl-PL" dirty="0"/>
+              <a:t> = *</a:t>
+            </a:r>
+          </a:p>
+          <a:p>
+            <a:r>
+              <a:rPr lang="pl-PL" dirty="0" err="1"/>
+              <a:t>Remember</a:t>
+            </a:r>
+            <a:r>
+              <a:rPr lang="pl-PL" dirty="0"/>
+              <a:t> </a:t>
+            </a:r>
+            <a:r>
+              <a:rPr lang="pl-PL" dirty="0" err="1"/>
+              <a:t>about</a:t>
+            </a:r>
+            <a:r>
+              <a:rPr lang="pl-PL" dirty="0"/>
+              <a:t> </a:t>
+            </a:r>
+            <a:r>
+              <a:rPr lang="pl-PL" dirty="0" err="1"/>
+              <a:t>adding</a:t>
+            </a:r>
+            <a:r>
+              <a:rPr lang="pl-PL" dirty="0"/>
+              <a:t> </a:t>
+            </a:r>
+            <a:r>
+              <a:rPr lang="pl-PL" dirty="0" err="1"/>
+              <a:t>valid</a:t>
+            </a:r>
+            <a:r>
+              <a:rPr lang="pl-PL" dirty="0"/>
+              <a:t> </a:t>
+            </a:r>
+            <a:r>
+              <a:rPr lang="pl-PL" dirty="0" err="1"/>
+              <a:t>Tables</a:t>
+            </a:r>
+            <a:r>
+              <a:rPr lang="pl-PL" dirty="0"/>
+              <a:t> </a:t>
+            </a:r>
+            <a:r>
+              <a:rPr lang="pl-PL" dirty="0" err="1"/>
+              <a:t>Permissions</a:t>
+            </a:r>
+            <a:r>
+              <a:rPr lang="pl-PL" dirty="0"/>
+              <a:t>!</a:t>
+            </a:r>
+          </a:p>
+          <a:p>
+            <a:pPr lvl="1"/>
+            <a:endParaRPr lang="pl-PL" dirty="0"/>
+          </a:p>
+          <a:p>
+            <a:r>
+              <a:rPr lang="pl-PL" dirty="0" err="1"/>
+              <a:t>Example</a:t>
+            </a:r>
+            <a:r>
+              <a:rPr lang="pl-PL" dirty="0"/>
+              <a:t> of API URL:</a:t>
+            </a:r>
+          </a:p>
+          <a:p>
+            <a:pPr lvl="1"/>
+            <a:r>
+              <a:rPr lang="pl-PL" dirty="0"/>
+              <a:t>https://pg-source-cms.powerappsportals.com/_api/pg_information</a:t>
+            </a:r>
+            <a:r>
+              <a:rPr lang="pl-PL" b="1" dirty="0"/>
+              <a:t>s</a:t>
+            </a:r>
+          </a:p>
+        </p:txBody>
+      </p:sp>
+    </p:spTree>
+    <p:extLst>
+      <p:ext uri="{BB962C8B-B14F-4D97-AF65-F5344CB8AC3E}">
+        <p14:creationId xmlns:p14="http://schemas.microsoft.com/office/powerpoint/2010/main" val="4097897589"/>
+      </p:ext>
+    </p:extLst>
+  </p:cSld>
+  <p:clrMapOvr>
+    <a:masterClrMapping/>
+  </p:clrMapOvr>
+</p:sld>
+</file>
+
+<file path=ppt/slides/slide7.xml><?xml version="1.0" encoding="utf-8"?>
+<p:sld xmlns:a="http://schemas.openxmlformats.org/drawingml/2006/main" xmlns:r="http://schemas.openxmlformats.org/officeDocument/2006/relationships" xmlns:p="http://schemas.openxmlformats.org/presentationml/2006/main">
+  <p:cSld>
+    <p:spTree>
+      <p:nvGrpSpPr>
+        <p:cNvPr id="1" name=""/>
+        <p:cNvGrpSpPr/>
+        <p:nvPr/>
+      </p:nvGrpSpPr>
+      <p:grpSpPr>
+        <a:xfrm>
+          <a:off x="0" y="0"/>
+          <a:ext cx="0" cy="0"/>
+          <a:chOff x="0" y="0"/>
+          <a:chExt cx="0" cy="0"/>
+        </a:xfrm>
+      </p:grpSpPr>
+      <p:sp>
+        <p:nvSpPr>
+          <p:cNvPr id="2" name="Title 1">
+            <a:extLst>
+              <a:ext uri="{FF2B5EF4-FFF2-40B4-BE49-F238E27FC236}">
+                <a16:creationId xmlns:a16="http://schemas.microsoft.com/office/drawing/2014/main" id="{0680CB1B-18D2-FDA2-41F4-C1378008186F}"/>
+              </a:ext>
+            </a:extLst>
+          </p:cNvPr>
+          <p:cNvSpPr>
+            <a:spLocks noGrp="1"/>
+          </p:cNvSpPr>
+          <p:nvPr>
+            <p:ph type="title"/>
+          </p:nvPr>
+        </p:nvSpPr>
+        <p:spPr/>
+        <p:txBody>
+          <a:bodyPr/>
+          <a:lstStyle/>
+          <a:p>
+            <a:r>
+              <a:rPr lang="pl-PL" dirty="0" err="1"/>
+              <a:t>Compose</a:t>
+            </a:r>
+            <a:r>
+              <a:rPr lang="pl-PL" dirty="0"/>
+              <a:t> HTTP </a:t>
+            </a:r>
+            <a:r>
+              <a:rPr lang="pl-PL" dirty="0" err="1"/>
+              <a:t>Request</a:t>
+            </a:r>
+            <a:r>
+              <a:rPr lang="pl-PL" dirty="0"/>
+              <a:t> and handle </a:t>
+            </a:r>
+            <a:r>
+              <a:rPr lang="en-US" dirty="0"/>
+              <a:t>CSRF (Cross-Site Request Forgery) token</a:t>
+            </a:r>
+            <a:endParaRPr lang="pl-PL" dirty="0"/>
+          </a:p>
+        </p:txBody>
+      </p:sp>
+      <p:sp>
+        <p:nvSpPr>
+          <p:cNvPr id="3" name="Content Placeholder 2">
+            <a:extLst>
+              <a:ext uri="{FF2B5EF4-FFF2-40B4-BE49-F238E27FC236}">
+                <a16:creationId xmlns:a16="http://schemas.microsoft.com/office/drawing/2014/main" id="{C9692A2D-6D68-89D1-4588-3353F8C2175A}"/>
+              </a:ext>
+            </a:extLst>
+          </p:cNvPr>
+          <p:cNvSpPr>
+            <a:spLocks noGrp="1"/>
+          </p:cNvSpPr>
+          <p:nvPr>
+            <p:ph idx="1"/>
+          </p:nvPr>
+        </p:nvSpPr>
+        <p:spPr/>
+        <p:txBody>
+          <a:bodyPr/>
+          <a:lstStyle/>
+          <a:p>
+            <a:r>
+              <a:rPr lang="pl-PL" dirty="0"/>
+              <a:t>Microsoft </a:t>
+            </a:r>
+            <a:r>
+              <a:rPr lang="pl-PL" dirty="0" err="1"/>
+              <a:t>documentation</a:t>
+            </a:r>
+            <a:r>
+              <a:rPr lang="pl-PL" dirty="0"/>
+              <a:t> (</a:t>
+            </a:r>
+            <a:r>
+              <a:rPr lang="pl-PL" dirty="0" err="1"/>
+              <a:t>JQuery</a:t>
+            </a:r>
+            <a:r>
+              <a:rPr lang="pl-PL" dirty="0"/>
+              <a:t>-style): </a:t>
+            </a:r>
+            <a:r>
+              <a:rPr lang="pl-PL" dirty="0">
+                <a:hlinkClick r:id="rId2"/>
+              </a:rPr>
+              <a:t>https://learn.microsoft.com/en-us/power-pages/configure/web-api-http-requests-handle-errors</a:t>
+            </a:r>
+            <a:r>
+              <a:rPr lang="pl-PL" dirty="0"/>
+              <a:t> </a:t>
+            </a:r>
+          </a:p>
+          <a:p>
+            <a:r>
+              <a:rPr lang="pl-PL" dirty="0" err="1"/>
+              <a:t>Example</a:t>
+            </a:r>
+            <a:r>
+              <a:rPr lang="pl-PL" dirty="0"/>
+              <a:t> of AJAX </a:t>
+            </a:r>
+            <a:r>
+              <a:rPr lang="pl-PL" dirty="0" err="1"/>
+              <a:t>helper</a:t>
+            </a:r>
+            <a:r>
+              <a:rPr lang="pl-PL" dirty="0"/>
+              <a:t>: </a:t>
+            </a:r>
+            <a:r>
+              <a:rPr lang="pl-PL" dirty="0">
+                <a:hlinkClick r:id="rId3"/>
+              </a:rPr>
+              <a:t>https://hacktheplatform.dev/blog/powerpages-spa-fetch-data-part-3</a:t>
+            </a:r>
+            <a:r>
+              <a:rPr lang="pl-PL" dirty="0"/>
+              <a:t> </a:t>
+            </a:r>
+          </a:p>
+        </p:txBody>
+      </p:sp>
+    </p:spTree>
+    <p:extLst>
+      <p:ext uri="{BB962C8B-B14F-4D97-AF65-F5344CB8AC3E}">
+        <p14:creationId xmlns:p14="http://schemas.microsoft.com/office/powerpoint/2010/main" val="3282399155"/>
+      </p:ext>
+    </p:extLst>
+  </p:cSld>
+  <p:clrMapOvr>
+    <a:masterClrMapping/>
+  </p:clrMapOvr>
+</p:sld>
+</file>
+
+<file path=ppt/slides/slide8.xml><?xml version="1.0" encoding="utf-8"?>
+<p:sld xmlns:a="http://schemas.openxmlformats.org/drawingml/2006/main" xmlns:r="http://schemas.openxmlformats.org/officeDocument/2006/relationships" xmlns:p="http://schemas.openxmlformats.org/presentationml/2006/main">
+  <p:cSld>
+    <p:spTree>
+      <p:nvGrpSpPr>
+        <p:cNvPr id="1" name=""/>
+        <p:cNvGrpSpPr/>
+        <p:nvPr/>
+      </p:nvGrpSpPr>
+      <p:grpSpPr>
+        <a:xfrm>
+          <a:off x="0" y="0"/>
+          <a:ext cx="0" cy="0"/>
+          <a:chOff x="0" y="0"/>
+          <a:chExt cx="0" cy="0"/>
+        </a:xfrm>
+      </p:grpSpPr>
+      <p:sp>
+        <p:nvSpPr>
+          <p:cNvPr id="2" name="Title 1">
+            <a:extLst>
+              <a:ext uri="{FF2B5EF4-FFF2-40B4-BE49-F238E27FC236}">
+                <a16:creationId xmlns:a16="http://schemas.microsoft.com/office/drawing/2014/main" id="{0E2C9D3D-0D4A-2430-B221-41160507BECA}"/>
+              </a:ext>
+            </a:extLst>
+          </p:cNvPr>
+          <p:cNvSpPr>
+            <a:spLocks noGrp="1"/>
+          </p:cNvSpPr>
+          <p:nvPr>
+            <p:ph type="title"/>
+          </p:nvPr>
+        </p:nvSpPr>
+        <p:spPr/>
+        <p:txBody>
+          <a:bodyPr/>
+          <a:lstStyle/>
+          <a:p>
+            <a:r>
+              <a:rPr lang="pl-PL" dirty="0" err="1"/>
+              <a:t>Make</a:t>
+            </a:r>
+            <a:r>
+              <a:rPr lang="pl-PL" dirty="0"/>
+              <a:t> AI </a:t>
+            </a:r>
+            <a:r>
+              <a:rPr lang="pl-PL" dirty="0" err="1"/>
+              <a:t>work</a:t>
+            </a:r>
+            <a:r>
+              <a:rPr lang="pl-PL" dirty="0"/>
+              <a:t>!</a:t>
+            </a:r>
+          </a:p>
+        </p:txBody>
+      </p:sp>
+      <p:sp>
+        <p:nvSpPr>
+          <p:cNvPr id="3" name="Content Placeholder 2">
+            <a:extLst>
+              <a:ext uri="{FF2B5EF4-FFF2-40B4-BE49-F238E27FC236}">
+                <a16:creationId xmlns:a16="http://schemas.microsoft.com/office/drawing/2014/main" id="{99C49376-5D79-D45D-ACF2-CEE04DEF3535}"/>
+              </a:ext>
+            </a:extLst>
+          </p:cNvPr>
+          <p:cNvSpPr>
+            <a:spLocks noGrp="1"/>
+          </p:cNvSpPr>
+          <p:nvPr>
+            <p:ph idx="1"/>
+          </p:nvPr>
+        </p:nvSpPr>
+        <p:spPr>
+          <a:xfrm>
+            <a:off x="838200" y="1690688"/>
+            <a:ext cx="10515600" cy="4486275"/>
+          </a:xfrm>
+        </p:spPr>
+        <p:txBody>
+          <a:bodyPr>
+            <a:normAutofit fontScale="62500" lnSpcReduction="20000"/>
+          </a:bodyPr>
+          <a:lstStyle/>
+          <a:p>
+            <a:pPr marL="0" indent="0">
+              <a:buNone/>
+            </a:pPr>
+            <a:endParaRPr lang="en-US" dirty="0"/>
+          </a:p>
+          <a:p>
+            <a:pPr marL="0" indent="0">
+              <a:buNone/>
+            </a:pPr>
+            <a:r>
+              <a:rPr lang="en-US" dirty="0"/>
+              <a:t>You are front-end developer working on Power Pages SPA portal implemented with React Framework. </a:t>
+            </a:r>
+          </a:p>
+          <a:p>
+            <a:pPr marL="0" indent="0">
+              <a:buNone/>
+            </a:pPr>
+            <a:endParaRPr lang="en-US" dirty="0"/>
+          </a:p>
+          <a:p>
+            <a:pPr marL="0" indent="0">
+              <a:buNone/>
+            </a:pPr>
+            <a:r>
+              <a:rPr lang="en-US" dirty="0"/>
+              <a:t>1. Create </a:t>
+            </a:r>
+            <a:r>
+              <a:rPr lang="en-US" dirty="0" err="1"/>
+              <a:t>InformationFeed</a:t>
+            </a:r>
+            <a:r>
+              <a:rPr lang="en-US" dirty="0"/>
+              <a:t> control using existing #file:InformationFeed.tsx  &amp; #file:InformationFeed.css  file. Control should present list of information retrieved from API and sorted by </a:t>
+            </a:r>
+            <a:r>
+              <a:rPr lang="en-US" dirty="0" err="1"/>
+              <a:t>CreatedOn</a:t>
+            </a:r>
+            <a:r>
+              <a:rPr lang="en-US" dirty="0"/>
+              <a:t> value. </a:t>
+            </a:r>
+          </a:p>
+          <a:p>
+            <a:pPr marL="0" indent="0">
+              <a:buNone/>
+            </a:pPr>
+            <a:r>
+              <a:rPr lang="en-US" dirty="0"/>
+              <a:t>Every single information should have the following fields: Title (text), Content (HTML generated by </a:t>
+            </a:r>
+            <a:r>
+              <a:rPr lang="en-US" dirty="0" err="1"/>
+              <a:t>RichText</a:t>
+            </a:r>
+            <a:r>
+              <a:rPr lang="en-US" dirty="0"/>
+              <a:t> control), </a:t>
+            </a:r>
+            <a:r>
+              <a:rPr lang="en-US" dirty="0" err="1"/>
+              <a:t>CreatedOn</a:t>
+            </a:r>
+            <a:r>
+              <a:rPr lang="en-US" dirty="0"/>
+              <a:t> (date and time). Styling should be similar to other components in the application. </a:t>
+            </a:r>
+          </a:p>
+          <a:p>
+            <a:pPr marL="0" indent="0">
+              <a:buNone/>
+            </a:pPr>
+            <a:endParaRPr lang="en-US" dirty="0"/>
+          </a:p>
+          <a:p>
+            <a:pPr marL="0" indent="0">
+              <a:buNone/>
+            </a:pPr>
+            <a:r>
+              <a:rPr lang="en-US" dirty="0"/>
+              <a:t>2. Data retrieval should take place inside </a:t>
+            </a:r>
+            <a:r>
+              <a:rPr lang="en-US" dirty="0" err="1"/>
+              <a:t>Home.tsx</a:t>
+            </a:r>
+            <a:r>
+              <a:rPr lang="en-US" dirty="0"/>
+              <a:t> file from _</a:t>
+            </a:r>
+            <a:r>
+              <a:rPr lang="en-US" dirty="0" err="1"/>
+              <a:t>api</a:t>
+            </a:r>
+            <a:r>
+              <a:rPr lang="en-US" dirty="0"/>
+              <a:t>/</a:t>
+            </a:r>
+            <a:r>
+              <a:rPr lang="en-US" dirty="0" err="1"/>
+              <a:t>pg_informations</a:t>
+            </a:r>
+            <a:r>
+              <a:rPr lang="en-US" dirty="0"/>
+              <a:t> Power Pages endpoint and with </a:t>
+            </a:r>
+            <a:r>
+              <a:rPr lang="en-US" dirty="0" err="1"/>
+              <a:t>safeFetch</a:t>
+            </a:r>
+            <a:r>
+              <a:rPr lang="en-US" dirty="0"/>
+              <a:t> from #file:webapi.ts  library. </a:t>
+            </a:r>
+            <a:r>
+              <a:rPr lang="en-US" dirty="0" err="1"/>
+              <a:t>InfromationFeed</a:t>
+            </a:r>
+            <a:r>
+              <a:rPr lang="en-US" dirty="0"/>
+              <a:t> control should be put inside this page and feed with list of information records retrieved from mentioned endpoint.</a:t>
+            </a:r>
+          </a:p>
+          <a:p>
+            <a:pPr marL="0" indent="0">
+              <a:buNone/>
+            </a:pPr>
+            <a:endParaRPr lang="en-US" dirty="0"/>
+          </a:p>
+          <a:p>
+            <a:pPr marL="0" indent="0">
+              <a:buNone/>
+            </a:pPr>
+            <a:r>
+              <a:rPr lang="en-US" dirty="0"/>
+              <a:t>Do not add any additional files by </a:t>
+            </a:r>
+            <a:r>
+              <a:rPr lang="en-US" dirty="0" err="1"/>
+              <a:t>youself</a:t>
+            </a:r>
+            <a:r>
+              <a:rPr lang="en-US" dirty="0"/>
+              <a:t>. Ask in case you would like to do it. Also do not make any git commits without asking about permission. </a:t>
+            </a:r>
+          </a:p>
+        </p:txBody>
+      </p:sp>
+    </p:spTree>
+    <p:extLst>
+      <p:ext uri="{BB962C8B-B14F-4D97-AF65-F5344CB8AC3E}">
+        <p14:creationId xmlns:p14="http://schemas.microsoft.com/office/powerpoint/2010/main" val="2122902642"/>
+      </p:ext>
+    </p:extLst>
+  </p:cSld>
+  <p:clrMapOvr>
+    <a:masterClrMapping/>
+  </p:clrMapOvr>
+</p:sld>
+</file>
+
+<file path=ppt/slides/slide9.xml><?xml version="1.0" encoding="utf-8"?>
+<p:sld xmlns:a="http://schemas.openxmlformats.org/drawingml/2006/main" xmlns:r="http://schemas.openxmlformats.org/officeDocument/2006/relationships" xmlns:p="http://schemas.openxmlformats.org/presentationml/2006/main">
+  <p:cSld>
+    <p:spTree>
+      <p:nvGrpSpPr>
+        <p:cNvPr id="1" name=""/>
+        <p:cNvGrpSpPr/>
+        <p:nvPr/>
+      </p:nvGrpSpPr>
+      <p:grpSpPr>
+        <a:xfrm>
+          <a:off x="0" y="0"/>
+          <a:ext cx="0" cy="0"/>
+          <a:chOff x="0" y="0"/>
+          <a:chExt cx="0" cy="0"/>
+        </a:xfrm>
+      </p:grpSpPr>
+      <p:sp>
+        <p:nvSpPr>
+          <p:cNvPr id="2" name="Title 1">
+            <a:extLst>
+              <a:ext uri="{FF2B5EF4-FFF2-40B4-BE49-F238E27FC236}">
+                <a16:creationId xmlns:a16="http://schemas.microsoft.com/office/drawing/2014/main" id="{47DA9414-2ABF-484E-3341-4A08DEC5600E}"/>
+              </a:ext>
+            </a:extLst>
+          </p:cNvPr>
+          <p:cNvSpPr>
+            <a:spLocks noGrp="1"/>
+          </p:cNvSpPr>
+          <p:nvPr>
+            <p:ph type="title"/>
+          </p:nvPr>
+        </p:nvSpPr>
+        <p:spPr/>
+        <p:txBody>
+          <a:bodyPr/>
+          <a:lstStyle/>
+          <a:p>
+            <a:r>
+              <a:rPr lang="pl-PL" dirty="0" err="1"/>
+              <a:t>Execute</a:t>
+            </a:r>
+            <a:r>
+              <a:rPr lang="pl-PL" dirty="0"/>
+              <a:t> Server </a:t>
+            </a:r>
+            <a:r>
+              <a:rPr lang="pl-PL" dirty="0" err="1"/>
+              <a:t>Side</a:t>
+            </a:r>
+            <a:r>
+              <a:rPr lang="pl-PL" dirty="0"/>
+              <a:t> </a:t>
+            </a:r>
+            <a:r>
+              <a:rPr lang="pl-PL" dirty="0" err="1"/>
+              <a:t>Logic</a:t>
+            </a:r>
+            <a:endParaRPr lang="pl-PL" dirty="0"/>
+          </a:p>
+        </p:txBody>
+      </p:sp>
+      <p:sp>
+        <p:nvSpPr>
+          <p:cNvPr id="3" name="Content Placeholder 2">
+            <a:extLst>
+              <a:ext uri="{FF2B5EF4-FFF2-40B4-BE49-F238E27FC236}">
+                <a16:creationId xmlns:a16="http://schemas.microsoft.com/office/drawing/2014/main" id="{A7C5003D-2626-4D71-3FBB-F4BD1FABFF2E}"/>
+              </a:ext>
+            </a:extLst>
+          </p:cNvPr>
+          <p:cNvSpPr>
+            <a:spLocks noGrp="1"/>
+          </p:cNvSpPr>
+          <p:nvPr>
+            <p:ph idx="1"/>
+          </p:nvPr>
+        </p:nvSpPr>
+        <p:spPr/>
+        <p:txBody>
+          <a:bodyPr/>
+          <a:lstStyle/>
+          <a:p>
+            <a:endParaRPr lang="pl-PL"/>
+          </a:p>
+        </p:txBody>
+      </p:sp>
+    </p:spTree>
+    <p:extLst>
+      <p:ext uri="{BB962C8B-B14F-4D97-AF65-F5344CB8AC3E}">
+        <p14:creationId xmlns:p14="http://schemas.microsoft.com/office/powerpoint/2010/main" val="3717220236"/>
+      </p:ext>
+    </p:extLst>
+  </p:cSld>
+  <p:clrMapOvr>
+    <a:masterClrMapping/>
+  </p:clrMapOvr>
+</p:sld>
+</file>
+
 <file path=ppt/theme/theme1.xml><?xml version="1.0" encoding="utf-8"?>
 <a:theme xmlns:a="http://schemas.openxmlformats.org/drawingml/2006/main" name="Office Theme">
   <a:themeElements>
@@ -7243,4 +8699,319 @@
     </a:ext>
   </a:extLst>
 </a:theme>
+</file>
+
+<file path=ppt/theme/theme2.xml><?xml version="1.0" encoding="utf-8"?>
+<a:theme xmlns:a="http://schemas.openxmlformats.org/drawingml/2006/main" name="Office Theme">
+  <a:themeElements>
+    <a:clrScheme name="Office">
+      <a:dk1>
+        <a:sysClr val="windowText" lastClr="000000"/>
+      </a:dk1>
+      <a:lt1>
+        <a:sysClr val="window" lastClr="FFFFFF"/>
+      </a:lt1>
+      <a:dk2>
+        <a:srgbClr val="0E2841"/>
+      </a:dk2>
+      <a:lt2>
+        <a:srgbClr val="E8E8E8"/>
+      </a:lt2>
+      <a:accent1>
+        <a:srgbClr val="156082"/>
+      </a:accent1>
+      <a:accent2>
+        <a:srgbClr val="E97132"/>
+      </a:accent2>
+      <a:accent3>
+        <a:srgbClr val="196B24"/>
+      </a:accent3>
+      <a:accent4>
+        <a:srgbClr val="0F9ED5"/>
+      </a:accent4>
+      <a:accent5>
+        <a:srgbClr val="A02B93"/>
+      </a:accent5>
+      <a:accent6>
+        <a:srgbClr val="4EA72E"/>
+      </a:accent6>
+      <a:hlink>
+        <a:srgbClr val="467886"/>
+      </a:hlink>
+      <a:folHlink>
+        <a:srgbClr val="96607D"/>
+      </a:folHlink>
+    </a:clrScheme>
+    <a:fontScheme name="Office">
+      <a:majorFont>
+        <a:latin typeface="Aptos Display" panose="02110004020202020204"/>
+        <a:ea typeface=""/>
+        <a:cs typeface=""/>
+        <a:font script="Jpan" typeface="游ゴシック Light"/>
+        <a:font script="Hang" typeface="맑은 고딕"/>
+        <a:font script="Hans" typeface="等线 Light"/>
+        <a:font script="Hant" typeface="新細明體"/>
+        <a:font script="Arab" typeface="Times New Roman"/>
+        <a:font script="Hebr" typeface="Times New Roman"/>
+        <a:font script="Thai" typeface="Angsana New"/>
+        <a:font script="Ethi" typeface="Nyala"/>
+        <a:font script="Beng" typeface="Vrinda"/>
+        <a:font script="Gujr" typeface="Shruti"/>
+        <a:font script="Khmr" typeface="MoolBoran"/>
+        <a:font script="Knda" typeface="Tunga"/>
+        <a:font script="Guru" typeface="Raavi"/>
+        <a:font script="Cans" typeface="Euphemia"/>
+        <a:font script="Cher" typeface="Plantagenet Cherokee"/>
+        <a:font script="Yiii" typeface="Microsoft Yi Baiti"/>
+        <a:font script="Tibt" typeface="Microsoft Himalaya"/>
+        <a:font script="Thaa" typeface="MV Boli"/>
+        <a:font script="Deva" typeface="Mangal"/>
+        <a:font script="Telu" typeface="Gautami"/>
+        <a:font script="Taml" typeface="Latha"/>
+        <a:font script="Syrc" typeface="Estrangelo Edessa"/>
+        <a:font script="Orya" typeface="Kalinga"/>
+        <a:font script="Mlym" typeface="Kartika"/>
+        <a:font script="Laoo" typeface="DokChampa"/>
+        <a:font script="Sinh" typeface="Iskoola Pota"/>
+        <a:font script="Mong" typeface="Mongolian Baiti"/>
+        <a:font script="Viet" typeface="Times New Roman"/>
+        <a:font script="Uigh" typeface="Microsoft Uighur"/>
+        <a:font script="Geor" typeface="Sylfaen"/>
+        <a:font script="Armn" typeface="Arial"/>
+        <a:font script="Bugi" typeface="Leelawadee UI"/>
+        <a:font script="Bopo" typeface="Microsoft JhengHei"/>
+        <a:font script="Java" typeface="Javanese Text"/>
+        <a:font script="Lisu" typeface="Segoe UI"/>
+        <a:font script="Mymr" typeface="Myanmar Text"/>
+        <a:font script="Nkoo" typeface="Ebrima"/>
+        <a:font script="Olck" typeface="Nirmala UI"/>
+        <a:font script="Osma" typeface="Ebrima"/>
+        <a:font script="Phag" typeface="Phagspa"/>
+        <a:font script="Syrn" typeface="Estrangelo Edessa"/>
+        <a:font script="Syrj" typeface="Estrangelo Edessa"/>
+        <a:font script="Syre" typeface="Estrangelo Edessa"/>
+        <a:font script="Sora" typeface="Nirmala UI"/>
+        <a:font script="Tale" typeface="Microsoft Tai Le"/>
+        <a:font script="Talu" typeface="Microsoft New Tai Lue"/>
+        <a:font script="Tfng" typeface="Ebrima"/>
+      </a:majorFont>
+      <a:minorFont>
+        <a:latin typeface="Aptos" panose="02110004020202020204"/>
+        <a:ea typeface=""/>
+        <a:cs typeface=""/>
+        <a:font script="Jpan" typeface="游ゴシック"/>
+        <a:font script="Hang" typeface="맑은 고딕"/>
+        <a:font script="Hans" typeface="等线"/>
+        <a:font script="Hant" typeface="新細明體"/>
+        <a:font script="Arab" typeface="Arial"/>
+        <a:font script="Hebr" typeface="Arial"/>
+        <a:font script="Thai" typeface="Cordia New"/>
+        <a:font script="Ethi" typeface="Nyala"/>
+        <a:font script="Beng" typeface="Vrinda"/>
+        <a:font script="Gujr" typeface="Shruti"/>
+        <a:font script="Khmr" typeface="DaunPenh"/>
+        <a:font script="Knda" typeface="Tunga"/>
+        <a:font script="Guru" typeface="Raavi"/>
+        <a:font script="Cans" typeface="Euphemia"/>
+        <a:font script="Cher" typeface="Plantagenet Cherokee"/>
+        <a:font script="Yiii" typeface="Microsoft Yi Baiti"/>
+        <a:font script="Tibt" typeface="Microsoft Himalaya"/>
+        <a:font script="Thaa" typeface="MV Boli"/>
+        <a:font script="Deva" typeface="Mangal"/>
+        <a:font script="Telu" typeface="Gautami"/>
+        <a:font script="Taml" typeface="Latha"/>
+        <a:font script="Syrc" typeface="Estrangelo Edessa"/>
+        <a:font script="Orya" typeface="Kalinga"/>
+        <a:font script="Mlym" typeface="Kartika"/>
+        <a:font script="Laoo" typeface="DokChampa"/>
+        <a:font script="Sinh" typeface="Iskoola Pota"/>
+        <a:font script="Mong" typeface="Mongolian Baiti"/>
+        <a:font script="Viet" typeface="Arial"/>
+        <a:font script="Uigh" typeface="Microsoft Uighur"/>
+        <a:font script="Geor" typeface="Sylfaen"/>
+        <a:font script="Armn" typeface="Arial"/>
+        <a:font script="Bugi" typeface="Leelawadee UI"/>
+        <a:font script="Bopo" typeface="Microsoft JhengHei"/>
+        <a:font script="Java" typeface="Javanese Text"/>
+        <a:font script="Lisu" typeface="Segoe UI"/>
+        <a:font script="Mymr" typeface="Myanmar Text"/>
+        <a:font script="Nkoo" typeface="Ebrima"/>
+        <a:font script="Olck" typeface="Nirmala UI"/>
+        <a:font script="Osma" typeface="Ebrima"/>
+        <a:font script="Phag" typeface="Phagspa"/>
+        <a:font script="Syrn" typeface="Estrangelo Edessa"/>
+        <a:font script="Syrj" typeface="Estrangelo Edessa"/>
+        <a:font script="Syre" typeface="Estrangelo Edessa"/>
+        <a:font script="Sora" typeface="Nirmala UI"/>
+        <a:font script="Tale" typeface="Microsoft Tai Le"/>
+        <a:font script="Talu" typeface="Microsoft New Tai Lue"/>
+        <a:font script="Tfng" typeface="Ebrima"/>
+      </a:minorFont>
+    </a:fontScheme>
+    <a:fmtScheme name="Office">
+      <a:fillStyleLst>
+        <a:solidFill>
+          <a:schemeClr val="phClr"/>
+        </a:solidFill>
+        <a:gradFill rotWithShape="1">
+          <a:gsLst>
+            <a:gs pos="0">
+              <a:schemeClr val="phClr">
+                <a:lumMod val="110000"/>
+                <a:satMod val="105000"/>
+                <a:tint val="67000"/>
+              </a:schemeClr>
+            </a:gs>
+            <a:gs pos="50000">
+              <a:schemeClr val="phClr">
+                <a:lumMod val="105000"/>
+                <a:satMod val="103000"/>
+                <a:tint val="73000"/>
+              </a:schemeClr>
+            </a:gs>
+            <a:gs pos="100000">
+              <a:schemeClr val="phClr">
+                <a:lumMod val="105000"/>
+                <a:satMod val="109000"/>
+                <a:tint val="81000"/>
+              </a:schemeClr>
+            </a:gs>
+          </a:gsLst>
+          <a:lin ang="5400000" scaled="0"/>
+        </a:gradFill>
+        <a:gradFill rotWithShape="1">
+          <a:gsLst>
+            <a:gs pos="0">
+              <a:schemeClr val="phClr">
+                <a:satMod val="103000"/>
+                <a:lumMod val="102000"/>
+                <a:tint val="94000"/>
+              </a:schemeClr>
+            </a:gs>
+            <a:gs pos="50000">
+              <a:schemeClr val="phClr">
+                <a:satMod val="110000"/>
+                <a:lumMod val="100000"/>
+                <a:shade val="100000"/>
+              </a:schemeClr>
+            </a:gs>
+            <a:gs pos="100000">
+              <a:schemeClr val="phClr">
+                <a:lumMod val="99000"/>
+                <a:satMod val="120000"/>
+                <a:shade val="78000"/>
+              </a:schemeClr>
+            </a:gs>
+          </a:gsLst>
+          <a:lin ang="5400000" scaled="0"/>
+        </a:gradFill>
+      </a:fillStyleLst>
+      <a:lnStyleLst>
+        <a:ln w="12700" cap="flat" cmpd="sng" algn="ctr">
+          <a:solidFill>
+            <a:schemeClr val="phClr"/>
+          </a:solidFill>
+          <a:prstDash val="solid"/>
+          <a:miter lim="800000"/>
+        </a:ln>
+        <a:ln w="19050" cap="flat" cmpd="sng" algn="ctr">
+          <a:solidFill>
+            <a:schemeClr val="phClr"/>
+          </a:solidFill>
+          <a:prstDash val="solid"/>
+          <a:miter lim="800000"/>
+        </a:ln>
+        <a:ln w="25400" cap="flat" cmpd="sng" algn="ctr">
+          <a:solidFill>
+            <a:schemeClr val="phClr"/>
+          </a:solidFill>
+          <a:prstDash val="solid"/>
+          <a:miter lim="800000"/>
+        </a:ln>
+      </a:lnStyleLst>
+      <a:effectStyleLst>
+        <a:effectStyle>
+          <a:effectLst/>
+        </a:effectStyle>
+        <a:effectStyle>
+          <a:effectLst/>
+        </a:effectStyle>
+        <a:effectStyle>
+          <a:effectLst>
+            <a:outerShdw blurRad="57150" dist="19050" dir="5400000" algn="ctr" rotWithShape="0">
+              <a:srgbClr val="000000">
+                <a:alpha val="63000"/>
+              </a:srgbClr>
+            </a:outerShdw>
+          </a:effectLst>
+        </a:effectStyle>
+      </a:effectStyleLst>
+      <a:bgFillStyleLst>
+        <a:solidFill>
+          <a:schemeClr val="phClr"/>
+        </a:solidFill>
+        <a:solidFill>
+          <a:schemeClr val="phClr">
+            <a:tint val="95000"/>
+            <a:satMod val="170000"/>
+          </a:schemeClr>
+        </a:solidFill>
+        <a:gradFill rotWithShape="1">
+          <a:gsLst>
+            <a:gs pos="0">
+              <a:schemeClr val="phClr">
+                <a:tint val="93000"/>
+                <a:satMod val="150000"/>
+                <a:shade val="98000"/>
+                <a:lumMod val="102000"/>
+              </a:schemeClr>
+            </a:gs>
+            <a:gs pos="50000">
+              <a:schemeClr val="phClr">
+                <a:tint val="98000"/>
+                <a:satMod val="130000"/>
+                <a:shade val="90000"/>
+                <a:lumMod val="103000"/>
+              </a:schemeClr>
+            </a:gs>
+            <a:gs pos="100000">
+              <a:schemeClr val="phClr">
+                <a:shade val="63000"/>
+                <a:satMod val="120000"/>
+              </a:schemeClr>
+            </a:gs>
+          </a:gsLst>
+          <a:lin ang="5400000" scaled="0"/>
+        </a:gradFill>
+      </a:bgFillStyleLst>
+    </a:fmtScheme>
+  </a:themeElements>
+  <a:objectDefaults>
+    <a:lnDef>
+      <a:spPr/>
+      <a:bodyPr/>
+      <a:lstStyle/>
+      <a:style>
+        <a:lnRef idx="2">
+          <a:schemeClr val="accent1"/>
+        </a:lnRef>
+        <a:fillRef idx="0">
+          <a:schemeClr val="accent1"/>
+        </a:fillRef>
+        <a:effectRef idx="1">
+          <a:schemeClr val="accent1"/>
+        </a:effectRef>
+        <a:fontRef idx="minor">
+          <a:schemeClr val="tx1"/>
+        </a:fontRef>
+      </a:style>
+    </a:lnDef>
+  </a:objectDefaults>
+  <a:extraClrSchemeLst/>
+  <a:extLst>
+    <a:ext uri="{05A4C25C-085E-4340-85A3-A5531E510DB2}">
+      <thm15:themeFamily xmlns:thm15="http://schemas.microsoft.com/office/thememl/2012/main" name="Office Theme" id="{2E142A2C-CD16-42D6-873A-C26D2A0506FA}" vid="{1BDDFF52-6CD6-40A5-AB3C-68EB2F1E4D0A}"/>
+    </a:ext>
+  </a:extLst>
+</a:theme>
 </file>
</xml_diff>